<commit_message>
Airbus Q3 2026: Faury quote, buyback and 2029 target from the corrected call transcript
Co-Authored-By: Claude Opus 5.5 <noreply@anthropic.com>
Claude-Session: https://claude.ai/code/session_014JFw9twk3me7qdaB3efhdc
</commit_message>
<xml_diff>
--- a/output/AIR_Q32026/Earnings_Update_AIR_Q32026.pptx
+++ b/output/AIR_Q32026/Earnings_Update_AIR_Q32026.pptx
@@ -1301,13 +1301,119 @@
       </p:sp>
       <p:sp>
         <p:nvSpPr>
-          <p:cNvPr id="9" name="Text 5"/>
-          <p:cNvSpPr txBox="1"/>
+          <p:cNvPr id="9" name="Shape 5"/>
+          <p:cNvSpPr/>
           <p:nvPr/>
         </p:nvSpPr>
         <p:spPr>
           <a:xfrm>
             <a:off x="539496" y="1602994"/>
+            <a:ext cx="42977" cy="536067"/>
+          </a:xfrm>
+          <a:prstGeom prst="rect">
+            <a:avLst/>
+          </a:prstGeom>
+          <a:solidFill>
+            <a:srgbClr val="FF6C0E"/>
+          </a:solidFill>
+          <a:ln w="12700">
+            <a:solidFill>
+              <a:srgbClr val="FF6C0E"/>
+            </a:solidFill>
+            <a:prstDash val="solid"/>
+          </a:ln>
+        </p:spPr>
+      </p:sp>
+      <p:sp>
+        <p:nvSpPr>
+          <p:cNvPr id="10" name="Text 6"/>
+          <p:cNvSpPr txBox="1"/>
+          <p:nvPr/>
+        </p:nvSpPr>
+        <p:spPr>
+          <a:xfrm>
+            <a:off x="722376" y="1621282"/>
+            <a:ext cx="6300216" cy="298323"/>
+          </a:xfrm>
+          <a:prstGeom prst="rect">
+            <a:avLst/>
+          </a:prstGeom>
+          <a:noFill/>
+          <a:ln/>
+        </p:spPr>
+        <p:txBody>
+          <a:bodyPr wrap="square" lIns="0" tIns="0" rIns="0" bIns="0" rtlCol="0" anchor="t"/>
+          <a:lstStyle/>
+          <a:p>
+            <a:pPr indent="0" marL="0">
+              <a:lnSpc>
+                <a:spcPct val="112500"/>
+              </a:lnSpc>
+              <a:buNone/>
+            </a:pPr>
+            <a:r>
+              <a:rPr lang="en-US" sz="870" b="1" dirty="0">
+                <a:solidFill>
+                  <a:srgbClr val="202945"/>
+                </a:solidFill>
+                <a:latin typeface="Nunito" pitchFamily="34" charset="0"/>
+                <a:ea typeface="Nunito" pitchFamily="34" charset="-122"/>
+                <a:cs typeface="Nunito" pitchFamily="34" charset="-120"/>
+              </a:rPr>
+              <a:t>“Overall, we feel comfortable with the ramp up. As you see, we are confirming the outlook for this year. We were comfortable enough at the Farnborough Airshow to give a 2029 mid-term target.”</a:t>
+            </a:r>
+            <a:endParaRPr lang="en-US" sz="870" dirty="0"/>
+          </a:p>
+        </p:txBody>
+      </p:sp>
+      <p:sp>
+        <p:nvSpPr>
+          <p:cNvPr id="11" name="Text 7"/>
+          <p:cNvSpPr txBox="1"/>
+          <p:nvPr/>
+        </p:nvSpPr>
+        <p:spPr>
+          <a:xfrm>
+            <a:off x="722376" y="1956181"/>
+            <a:ext cx="6300216" cy="155448"/>
+          </a:xfrm>
+          <a:prstGeom prst="rect">
+            <a:avLst/>
+          </a:prstGeom>
+          <a:noFill/>
+          <a:ln/>
+        </p:spPr>
+        <p:txBody>
+          <a:bodyPr wrap="square" lIns="0" tIns="0" rIns="0" bIns="0" rtlCol="0" anchor="t"/>
+          <a:lstStyle/>
+          <a:p>
+            <a:pPr indent="0" marL="0">
+              <a:buNone/>
+            </a:pPr>
+            <a:r>
+              <a:rPr lang="en-US" sz="700" b="1" dirty="0">
+                <a:solidFill>
+                  <a:srgbClr val="6B7280"/>
+                </a:solidFill>
+                <a:latin typeface="Nunito" pitchFamily="34" charset="0"/>
+                <a:ea typeface="Nunito" pitchFamily="34" charset="-122"/>
+                <a:cs typeface="Nunito" pitchFamily="34" charset="-120"/>
+              </a:rPr>
+              <a:t>Guillaume Faury, CEO, Q3 2026 earnings call, 28 October 2026</a:t>
+            </a:r>
+            <a:endParaRPr lang="en-US" sz="700" dirty="0"/>
+          </a:p>
+        </p:txBody>
+      </p:sp>
+      <p:sp>
+        <p:nvSpPr>
+          <p:cNvPr id="12" name="Text 8"/>
+          <p:cNvSpPr txBox="1"/>
+          <p:nvPr/>
+        </p:nvSpPr>
+        <p:spPr>
+          <a:xfrm>
+            <a:off x="539496" y="2257933"/>
             <a:ext cx="6483096" cy="332080"/>
           </a:xfrm>
           <a:prstGeom prst="rect">
@@ -1343,13 +1449,13 @@
       </p:sp>
       <p:sp>
         <p:nvSpPr>
-          <p:cNvPr id="10" name="Text 6"/>
-          <p:cNvSpPr txBox="1"/>
-          <p:nvPr/>
-        </p:nvSpPr>
-        <p:spPr>
-          <a:xfrm>
-            <a:off x="539496" y="2053946"/>
+          <p:cNvPr id="13" name="Text 9"/>
+          <p:cNvSpPr txBox="1"/>
+          <p:nvPr/>
+        </p:nvSpPr>
+        <p:spPr>
+          <a:xfrm>
+            <a:off x="539496" y="2708885"/>
             <a:ext cx="6483096" cy="219456"/>
           </a:xfrm>
           <a:prstGeom prst="rect">
@@ -1382,13 +1488,13 @@
       </p:sp>
       <p:sp>
         <p:nvSpPr>
-          <p:cNvPr id="11" name="Text 7"/>
-          <p:cNvSpPr txBox="1"/>
-          <p:nvPr/>
-        </p:nvSpPr>
-        <p:spPr>
-          <a:xfrm>
-            <a:off x="539496" y="2314550"/>
+          <p:cNvPr id="14" name="Text 10"/>
+          <p:cNvSpPr txBox="1"/>
+          <p:nvPr/>
+        </p:nvSpPr>
+        <p:spPr>
+          <a:xfrm>
+            <a:off x="539496" y="2969489"/>
             <a:ext cx="576072" cy="156896"/>
           </a:xfrm>
           <a:prstGeom prst="rect">
@@ -1421,13 +1527,13 @@
       </p:sp>
       <p:sp>
         <p:nvSpPr>
-          <p:cNvPr id="12" name="Text 8"/>
-          <p:cNvSpPr txBox="1"/>
-          <p:nvPr/>
-        </p:nvSpPr>
-        <p:spPr>
-          <a:xfrm>
-            <a:off x="1133856" y="2291690"/>
+          <p:cNvPr id="15" name="Text 11"/>
+          <p:cNvSpPr txBox="1"/>
+          <p:nvPr/>
+        </p:nvSpPr>
+        <p:spPr>
+          <a:xfrm>
+            <a:off x="1133856" y="2946629"/>
             <a:ext cx="5888736" cy="156896"/>
           </a:xfrm>
           <a:prstGeom prst="rect">
@@ -1463,13 +1569,13 @@
       </p:sp>
       <p:sp>
         <p:nvSpPr>
-          <p:cNvPr id="13" name="Text 9"/>
-          <p:cNvSpPr txBox="1"/>
-          <p:nvPr/>
-        </p:nvSpPr>
-        <p:spPr>
-          <a:xfrm>
-            <a:off x="539496" y="2517165"/>
+          <p:cNvPr id="16" name="Text 12"/>
+          <p:cNvSpPr txBox="1"/>
+          <p:nvPr/>
+        </p:nvSpPr>
+        <p:spPr>
+          <a:xfrm>
+            <a:off x="539496" y="3172104"/>
             <a:ext cx="576072" cy="156896"/>
           </a:xfrm>
           <a:prstGeom prst="rect">
@@ -1502,13 +1608,13 @@
       </p:sp>
       <p:sp>
         <p:nvSpPr>
-          <p:cNvPr id="14" name="Text 10"/>
-          <p:cNvSpPr txBox="1"/>
-          <p:nvPr/>
-        </p:nvSpPr>
-        <p:spPr>
-          <a:xfrm>
-            <a:off x="1133856" y="2494305"/>
+          <p:cNvPr id="17" name="Text 13"/>
+          <p:cNvSpPr txBox="1"/>
+          <p:nvPr/>
+        </p:nvSpPr>
+        <p:spPr>
+          <a:xfrm>
+            <a:off x="1133856" y="3149244"/>
             <a:ext cx="5888736" cy="156896"/>
           </a:xfrm>
           <a:prstGeom prst="rect">
@@ -1544,13 +1650,13 @@
       </p:sp>
       <p:sp>
         <p:nvSpPr>
-          <p:cNvPr id="15" name="Text 11"/>
-          <p:cNvSpPr txBox="1"/>
-          <p:nvPr/>
-        </p:nvSpPr>
-        <p:spPr>
-          <a:xfrm>
-            <a:off x="539496" y="2719781"/>
+          <p:cNvPr id="18" name="Text 14"/>
+          <p:cNvSpPr txBox="1"/>
+          <p:nvPr/>
+        </p:nvSpPr>
+        <p:spPr>
+          <a:xfrm>
+            <a:off x="539496" y="3374720"/>
             <a:ext cx="576072" cy="156896"/>
           </a:xfrm>
           <a:prstGeom prst="rect">
@@ -1583,13 +1689,13 @@
       </p:sp>
       <p:sp>
         <p:nvSpPr>
-          <p:cNvPr id="16" name="Text 12"/>
-          <p:cNvSpPr txBox="1"/>
-          <p:nvPr/>
-        </p:nvSpPr>
-        <p:spPr>
-          <a:xfrm>
-            <a:off x="1133856" y="2696921"/>
+          <p:cNvPr id="19" name="Text 15"/>
+          <p:cNvSpPr txBox="1"/>
+          <p:nvPr/>
+        </p:nvSpPr>
+        <p:spPr>
+          <a:xfrm>
+            <a:off x="1133856" y="3351860"/>
             <a:ext cx="5888736" cy="156896"/>
           </a:xfrm>
           <a:prstGeom prst="rect">
@@ -1625,13 +1731,13 @@
       </p:sp>
       <p:sp>
         <p:nvSpPr>
-          <p:cNvPr id="17" name="Text 13"/>
-          <p:cNvSpPr txBox="1"/>
-          <p:nvPr/>
-        </p:nvSpPr>
-        <p:spPr>
-          <a:xfrm>
-            <a:off x="539496" y="2922397"/>
+          <p:cNvPr id="20" name="Text 16"/>
+          <p:cNvSpPr txBox="1"/>
+          <p:nvPr/>
+        </p:nvSpPr>
+        <p:spPr>
+          <a:xfrm>
+            <a:off x="539496" y="3577336"/>
             <a:ext cx="576072" cy="156896"/>
           </a:xfrm>
           <a:prstGeom prst="rect">
@@ -1664,13 +1770,13 @@
       </p:sp>
       <p:sp>
         <p:nvSpPr>
-          <p:cNvPr id="18" name="Text 14"/>
-          <p:cNvSpPr txBox="1"/>
-          <p:nvPr/>
-        </p:nvSpPr>
-        <p:spPr>
-          <a:xfrm>
-            <a:off x="1133856" y="2899537"/>
+          <p:cNvPr id="21" name="Text 17"/>
+          <p:cNvSpPr txBox="1"/>
+          <p:nvPr/>
+        </p:nvSpPr>
+        <p:spPr>
+          <a:xfrm>
+            <a:off x="1133856" y="3554476"/>
             <a:ext cx="5888736" cy="156896"/>
           </a:xfrm>
           <a:prstGeom prst="rect">
@@ -1706,13 +1812,13 @@
       </p:sp>
       <p:sp>
         <p:nvSpPr>
-          <p:cNvPr id="19" name="Shape 15"/>
+          <p:cNvPr id="22" name="Shape 18"/>
           <p:cNvSpPr/>
           <p:nvPr/>
         </p:nvSpPr>
         <p:spPr>
           <a:xfrm>
-            <a:off x="539496" y="3184449"/>
+            <a:off x="539496" y="3839388"/>
             <a:ext cx="6483096" cy="640080"/>
           </a:xfrm>
           <a:prstGeom prst="roundRect">
@@ -1733,13 +1839,13 @@
       </p:sp>
       <p:sp>
         <p:nvSpPr>
-          <p:cNvPr id="20" name="Text 16"/>
-          <p:cNvSpPr txBox="1"/>
-          <p:nvPr/>
-        </p:nvSpPr>
-        <p:spPr>
-          <a:xfrm>
-            <a:off x="649224" y="3257601"/>
+          <p:cNvPr id="23" name="Text 19"/>
+          <p:cNvSpPr txBox="1"/>
+          <p:nvPr/>
+        </p:nvSpPr>
+        <p:spPr>
+          <a:xfrm>
+            <a:off x="649224" y="3912540"/>
             <a:ext cx="1437894" cy="137160"/>
           </a:xfrm>
           <a:prstGeom prst="rect">
@@ -1772,13 +1878,13 @@
       </p:sp>
       <p:sp>
         <p:nvSpPr>
-          <p:cNvPr id="21" name="Text 17"/>
-          <p:cNvSpPr txBox="1"/>
-          <p:nvPr/>
-        </p:nvSpPr>
-        <p:spPr>
-          <a:xfrm>
-            <a:off x="649224" y="3394761"/>
+          <p:cNvPr id="24" name="Text 20"/>
+          <p:cNvSpPr txBox="1"/>
+          <p:nvPr/>
+        </p:nvSpPr>
+        <p:spPr>
+          <a:xfrm>
+            <a:off x="649224" y="4049700"/>
             <a:ext cx="1437894" cy="201168"/>
           </a:xfrm>
           <a:prstGeom prst="rect">
@@ -1811,13 +1917,13 @@
       </p:sp>
       <p:sp>
         <p:nvSpPr>
-          <p:cNvPr id="22" name="Text 18"/>
-          <p:cNvSpPr txBox="1"/>
-          <p:nvPr/>
-        </p:nvSpPr>
-        <p:spPr>
-          <a:xfrm>
-            <a:off x="649224" y="3605073"/>
+          <p:cNvPr id="25" name="Text 21"/>
+          <p:cNvSpPr txBox="1"/>
+          <p:nvPr/>
+        </p:nvSpPr>
+        <p:spPr>
+          <a:xfrm>
+            <a:off x="649224" y="4260012"/>
             <a:ext cx="1437894" cy="137160"/>
           </a:xfrm>
           <a:prstGeom prst="rect">
@@ -1850,13 +1956,13 @@
       </p:sp>
       <p:sp>
         <p:nvSpPr>
-          <p:cNvPr id="23" name="Shape 19"/>
+          <p:cNvPr id="26" name="Shape 22"/>
           <p:cNvSpPr/>
           <p:nvPr/>
         </p:nvSpPr>
         <p:spPr>
           <a:xfrm>
-            <a:off x="2160270" y="3184449"/>
+            <a:off x="2160270" y="3839388"/>
             <a:ext cx="0" cy="640080"/>
           </a:xfrm>
           <a:prstGeom prst="line">
@@ -1873,13 +1979,13 @@
       </p:sp>
       <p:sp>
         <p:nvSpPr>
-          <p:cNvPr id="24" name="Text 20"/>
-          <p:cNvSpPr txBox="1"/>
-          <p:nvPr/>
-        </p:nvSpPr>
-        <p:spPr>
-          <a:xfrm>
-            <a:off x="2269998" y="3257601"/>
+          <p:cNvPr id="27" name="Text 23"/>
+          <p:cNvSpPr txBox="1"/>
+          <p:nvPr/>
+        </p:nvSpPr>
+        <p:spPr>
+          <a:xfrm>
+            <a:off x="2269998" y="3912540"/>
             <a:ext cx="1437894" cy="137160"/>
           </a:xfrm>
           <a:prstGeom prst="rect">
@@ -1912,13 +2018,13 @@
       </p:sp>
       <p:sp>
         <p:nvSpPr>
-          <p:cNvPr id="25" name="Text 21"/>
-          <p:cNvSpPr txBox="1"/>
-          <p:nvPr/>
-        </p:nvSpPr>
-        <p:spPr>
-          <a:xfrm>
-            <a:off x="2269998" y="3394761"/>
+          <p:cNvPr id="28" name="Text 24"/>
+          <p:cNvSpPr txBox="1"/>
+          <p:nvPr/>
+        </p:nvSpPr>
+        <p:spPr>
+          <a:xfrm>
+            <a:off x="2269998" y="4049700"/>
             <a:ext cx="1437894" cy="201168"/>
           </a:xfrm>
           <a:prstGeom prst="rect">
@@ -1951,13 +2057,13 @@
       </p:sp>
       <p:sp>
         <p:nvSpPr>
-          <p:cNvPr id="26" name="Text 22"/>
-          <p:cNvSpPr txBox="1"/>
-          <p:nvPr/>
-        </p:nvSpPr>
-        <p:spPr>
-          <a:xfrm>
-            <a:off x="2269998" y="3605073"/>
+          <p:cNvPr id="29" name="Text 25"/>
+          <p:cNvSpPr txBox="1"/>
+          <p:nvPr/>
+        </p:nvSpPr>
+        <p:spPr>
+          <a:xfrm>
+            <a:off x="2269998" y="4260012"/>
             <a:ext cx="1437894" cy="137160"/>
           </a:xfrm>
           <a:prstGeom prst="rect">
@@ -1990,13 +2096,13 @@
       </p:sp>
       <p:sp>
         <p:nvSpPr>
-          <p:cNvPr id="27" name="Shape 23"/>
+          <p:cNvPr id="30" name="Shape 26"/>
           <p:cNvSpPr/>
           <p:nvPr/>
         </p:nvSpPr>
         <p:spPr>
           <a:xfrm>
-            <a:off x="3781044" y="3184449"/>
+            <a:off x="3781044" y="3839388"/>
             <a:ext cx="0" cy="640080"/>
           </a:xfrm>
           <a:prstGeom prst="line">
@@ -2013,13 +2119,13 @@
       </p:sp>
       <p:sp>
         <p:nvSpPr>
-          <p:cNvPr id="28" name="Text 24"/>
-          <p:cNvSpPr txBox="1"/>
-          <p:nvPr/>
-        </p:nvSpPr>
-        <p:spPr>
-          <a:xfrm>
-            <a:off x="3890772" y="3257601"/>
+          <p:cNvPr id="31" name="Text 27"/>
+          <p:cNvSpPr txBox="1"/>
+          <p:nvPr/>
+        </p:nvSpPr>
+        <p:spPr>
+          <a:xfrm>
+            <a:off x="3890772" y="3912540"/>
             <a:ext cx="1437894" cy="137160"/>
           </a:xfrm>
           <a:prstGeom prst="rect">
@@ -2052,13 +2158,13 @@
       </p:sp>
       <p:sp>
         <p:nvSpPr>
-          <p:cNvPr id="29" name="Text 25"/>
-          <p:cNvSpPr txBox="1"/>
-          <p:nvPr/>
-        </p:nvSpPr>
-        <p:spPr>
-          <a:xfrm>
-            <a:off x="3890772" y="3394761"/>
+          <p:cNvPr id="32" name="Text 28"/>
+          <p:cNvSpPr txBox="1"/>
+          <p:nvPr/>
+        </p:nvSpPr>
+        <p:spPr>
+          <a:xfrm>
+            <a:off x="3890772" y="4049700"/>
             <a:ext cx="1437894" cy="201168"/>
           </a:xfrm>
           <a:prstGeom prst="rect">
@@ -2091,13 +2197,13 @@
       </p:sp>
       <p:sp>
         <p:nvSpPr>
-          <p:cNvPr id="30" name="Text 26"/>
-          <p:cNvSpPr txBox="1"/>
-          <p:nvPr/>
-        </p:nvSpPr>
-        <p:spPr>
-          <a:xfrm>
-            <a:off x="3890772" y="3605073"/>
+          <p:cNvPr id="33" name="Text 29"/>
+          <p:cNvSpPr txBox="1"/>
+          <p:nvPr/>
+        </p:nvSpPr>
+        <p:spPr>
+          <a:xfrm>
+            <a:off x="3890772" y="4260012"/>
             <a:ext cx="1437894" cy="137160"/>
           </a:xfrm>
           <a:prstGeom prst="rect">
@@ -2130,13 +2236,13 @@
       </p:sp>
       <p:sp>
         <p:nvSpPr>
-          <p:cNvPr id="31" name="Shape 27"/>
+          <p:cNvPr id="34" name="Shape 30"/>
           <p:cNvSpPr/>
           <p:nvPr/>
         </p:nvSpPr>
         <p:spPr>
           <a:xfrm>
-            <a:off x="5401818" y="3184449"/>
+            <a:off x="5401818" y="3839388"/>
             <a:ext cx="0" cy="640080"/>
           </a:xfrm>
           <a:prstGeom prst="line">
@@ -2153,13 +2259,13 @@
       </p:sp>
       <p:sp>
         <p:nvSpPr>
-          <p:cNvPr id="32" name="Text 28"/>
-          <p:cNvSpPr txBox="1"/>
-          <p:nvPr/>
-        </p:nvSpPr>
-        <p:spPr>
-          <a:xfrm>
-            <a:off x="5511546" y="3257601"/>
+          <p:cNvPr id="35" name="Text 31"/>
+          <p:cNvSpPr txBox="1"/>
+          <p:nvPr/>
+        </p:nvSpPr>
+        <p:spPr>
+          <a:xfrm>
+            <a:off x="5511546" y="3912540"/>
             <a:ext cx="1437894" cy="137160"/>
           </a:xfrm>
           <a:prstGeom prst="rect">
@@ -2192,13 +2298,13 @@
       </p:sp>
       <p:sp>
         <p:nvSpPr>
-          <p:cNvPr id="33" name="Text 29"/>
-          <p:cNvSpPr txBox="1"/>
-          <p:nvPr/>
-        </p:nvSpPr>
-        <p:spPr>
-          <a:xfrm>
-            <a:off x="5511546" y="3394761"/>
+          <p:cNvPr id="36" name="Text 32"/>
+          <p:cNvSpPr txBox="1"/>
+          <p:nvPr/>
+        </p:nvSpPr>
+        <p:spPr>
+          <a:xfrm>
+            <a:off x="5511546" y="4049700"/>
             <a:ext cx="1437894" cy="201168"/>
           </a:xfrm>
           <a:prstGeom prst="rect">
@@ -2231,13 +2337,13 @@
       </p:sp>
       <p:sp>
         <p:nvSpPr>
-          <p:cNvPr id="34" name="Text 30"/>
-          <p:cNvSpPr txBox="1"/>
-          <p:nvPr/>
-        </p:nvSpPr>
-        <p:spPr>
-          <a:xfrm>
-            <a:off x="5511546" y="3605073"/>
+          <p:cNvPr id="37" name="Text 33"/>
+          <p:cNvSpPr txBox="1"/>
+          <p:nvPr/>
+        </p:nvSpPr>
+        <p:spPr>
+          <a:xfrm>
+            <a:off x="5511546" y="4260012"/>
             <a:ext cx="1437894" cy="137160"/>
           </a:xfrm>
           <a:prstGeom prst="rect">
@@ -2270,13 +2376,13 @@
       </p:sp>
       <p:sp>
         <p:nvSpPr>
-          <p:cNvPr id="35" name="Text 31"/>
-          <p:cNvSpPr txBox="1"/>
-          <p:nvPr/>
-        </p:nvSpPr>
-        <p:spPr>
-          <a:xfrm>
-            <a:off x="539496" y="3943401"/>
+          <p:cNvPr id="38" name="Text 34"/>
+          <p:cNvSpPr txBox="1"/>
+          <p:nvPr/>
+        </p:nvSpPr>
+        <p:spPr>
+          <a:xfrm>
+            <a:off x="539496" y="4598340"/>
             <a:ext cx="6483096" cy="219456"/>
           </a:xfrm>
           <a:prstGeom prst="rect">
@@ -2309,13 +2415,13 @@
       </p:sp>
       <p:sp>
         <p:nvSpPr>
-          <p:cNvPr id="36" name="Text 32"/>
-          <p:cNvSpPr txBox="1"/>
-          <p:nvPr/>
-        </p:nvSpPr>
-        <p:spPr>
-          <a:xfrm>
-            <a:off x="539496" y="4190289"/>
+          <p:cNvPr id="39" name="Text 35"/>
+          <p:cNvSpPr txBox="1"/>
+          <p:nvPr/>
+        </p:nvSpPr>
+        <p:spPr>
+          <a:xfrm>
+            <a:off x="539496" y="4845228"/>
             <a:ext cx="6483096" cy="488975"/>
           </a:xfrm>
           <a:prstGeom prst="rect">
@@ -2343,7 +2449,7 @@
                 <a:ea typeface="Nunito" pitchFamily="34" charset="-122"/>
                 <a:cs typeface="Nunito" pitchFamily="34" charset="-120"/>
               </a:rPr>
-              <a:t>Q3 adjusted EBIT matched consensus while revenue missed by 5% and free cash flow by about EUR 0.4bn, yet the shares closed 3.3% higher on 29 October, against 0.8% for the Stoxx Europe 600. The guide held and orders keep building: 1,105 net orders in nine months, more than double last year. The case now rests on delivering Q4.</a:t>
+              <a:t>Q3 adjusted EBIT matched consensus while revenue missed by 5% and free cash flow by about EUR 0.4bn, yet the shares closed 3.3% higher on 29 October, against 0.8% for the Stoxx Europe 600. The guide and the buyback plan held, and orders keep building: 1,105 net orders in nine months, double last year. The case now rests on delivering Q4.</a:t>
             </a:r>
             <a:endParaRPr lang="en-US" sz="870" dirty="0"/>
           </a:p>
@@ -2351,13 +2457,13 @@
       </p:sp>
       <p:sp>
         <p:nvSpPr>
-          <p:cNvPr id="37" name="Text 33"/>
-          <p:cNvSpPr txBox="1"/>
-          <p:nvPr/>
-        </p:nvSpPr>
-        <p:spPr>
-          <a:xfrm>
-            <a:off x="539496" y="4758817"/>
+          <p:cNvPr id="40" name="Text 36"/>
+          <p:cNvSpPr txBox="1"/>
+          <p:nvPr/>
+        </p:nvSpPr>
+        <p:spPr>
+          <a:xfrm>
+            <a:off x="539496" y="5413756"/>
             <a:ext cx="6483096" cy="173736"/>
           </a:xfrm>
           <a:prstGeom prst="rect">
@@ -2404,13 +2510,13 @@
       </p:sp>
       <p:sp>
         <p:nvSpPr>
-          <p:cNvPr id="38" name="Text 34"/>
-          <p:cNvSpPr txBox="1"/>
-          <p:nvPr/>
-        </p:nvSpPr>
-        <p:spPr>
-          <a:xfrm>
-            <a:off x="539496" y="4932553"/>
+          <p:cNvPr id="41" name="Text 37"/>
+          <p:cNvSpPr txBox="1"/>
+          <p:nvPr/>
+        </p:nvSpPr>
+        <p:spPr>
+          <a:xfrm>
+            <a:off x="539496" y="5587492"/>
             <a:ext cx="6483096" cy="115570"/>
           </a:xfrm>
           <a:prstGeom prst="rect">
@@ -2446,7 +2552,7 @@
       </p:sp>
       <p:pic>
         <p:nvPicPr>
-          <p:cNvPr id="39" name="Image 2" descr="/home/claude/air/c1_crop.png">    </p:cNvPr>
+          <p:cNvPr id="42" name="Image 2" descr="/home/claude/air/c1_crop.png">    </p:cNvPr>
           <p:cNvPicPr>
             <a:picLocks noChangeAspect="1"/>
           </p:cNvPicPr>
@@ -2460,8 +2566,8 @@
         </p:blipFill>
         <p:spPr>
           <a:xfrm>
-            <a:off x="1511960" y="5093843"/>
-            <a:ext cx="4538167" cy="1415908"/>
+            <a:off x="1641622" y="5748782"/>
+            <a:ext cx="4278843" cy="1334999"/>
           </a:xfrm>
           <a:prstGeom prst="rect">
             <a:avLst/>
@@ -2470,13 +2576,13 @@
       </p:pic>
       <p:sp>
         <p:nvSpPr>
-          <p:cNvPr id="40" name="Text 35"/>
-          <p:cNvSpPr txBox="1"/>
-          <p:nvPr/>
-        </p:nvSpPr>
-        <p:spPr>
-          <a:xfrm>
-            <a:off x="539496" y="6564615"/>
+          <p:cNvPr id="43" name="Text 38"/>
+          <p:cNvSpPr txBox="1"/>
+          <p:nvPr/>
+        </p:nvSpPr>
+        <p:spPr>
+          <a:xfrm>
+            <a:off x="539496" y="7138645"/>
             <a:ext cx="6483096" cy="488975"/>
           </a:xfrm>
           <a:prstGeom prst="rect">
@@ -2512,13 +2618,13 @@
       </p:sp>
       <p:sp>
         <p:nvSpPr>
-          <p:cNvPr id="41" name="Text 36"/>
-          <p:cNvSpPr txBox="1"/>
-          <p:nvPr/>
-        </p:nvSpPr>
-        <p:spPr>
-          <a:xfrm>
-            <a:off x="658368" y="7215439"/>
+          <p:cNvPr id="44" name="Text 39"/>
+          <p:cNvSpPr txBox="1"/>
+          <p:nvPr/>
+        </p:nvSpPr>
+        <p:spPr>
+          <a:xfrm>
+            <a:off x="658368" y="7789469"/>
             <a:ext cx="6245352" cy="219456"/>
           </a:xfrm>
           <a:prstGeom prst="rect">
@@ -2551,13 +2657,13 @@
       </p:sp>
       <p:sp>
         <p:nvSpPr>
-          <p:cNvPr id="42" name="Text 37"/>
-          <p:cNvSpPr txBox="1"/>
-          <p:nvPr/>
-        </p:nvSpPr>
-        <p:spPr>
-          <a:xfrm>
-            <a:off x="658368" y="7462327"/>
+          <p:cNvPr id="45" name="Text 40"/>
+          <p:cNvSpPr txBox="1"/>
+          <p:nvPr/>
+        </p:nvSpPr>
+        <p:spPr>
+          <a:xfrm>
+            <a:off x="658368" y="8036357"/>
             <a:ext cx="6245352" cy="802767"/>
           </a:xfrm>
           <a:prstGeom prst="rect">
@@ -2593,13 +2699,13 @@
       </p:sp>
       <p:sp>
         <p:nvSpPr>
-          <p:cNvPr id="43" name="Shape 38"/>
+          <p:cNvPr id="46" name="Shape 41"/>
           <p:cNvSpPr/>
           <p:nvPr/>
         </p:nvSpPr>
         <p:spPr>
           <a:xfrm>
-            <a:off x="658368" y="8344647"/>
+            <a:off x="658368" y="8918677"/>
             <a:ext cx="6245352" cy="0"/>
           </a:xfrm>
           <a:prstGeom prst="line">
@@ -2616,13 +2722,13 @@
       </p:sp>
       <p:sp>
         <p:nvSpPr>
-          <p:cNvPr id="44" name="Shape 39"/>
+          <p:cNvPr id="47" name="Shape 42"/>
           <p:cNvSpPr/>
           <p:nvPr/>
         </p:nvSpPr>
         <p:spPr>
           <a:xfrm>
-            <a:off x="3781044" y="8454375"/>
+            <a:off x="3781044" y="9028405"/>
             <a:ext cx="0" cy="828751"/>
           </a:xfrm>
           <a:prstGeom prst="line">
@@ -2639,13 +2745,13 @@
       </p:sp>
       <p:sp>
         <p:nvSpPr>
-          <p:cNvPr id="45" name="Text 40"/>
-          <p:cNvSpPr txBox="1"/>
-          <p:nvPr/>
-        </p:nvSpPr>
-        <p:spPr>
-          <a:xfrm>
-            <a:off x="658368" y="8454375"/>
+          <p:cNvPr id="48" name="Text 43"/>
+          <p:cNvSpPr txBox="1"/>
+          <p:nvPr/>
+        </p:nvSpPr>
+        <p:spPr>
+          <a:xfrm>
+            <a:off x="658368" y="9028405"/>
             <a:ext cx="2939796" cy="155448"/>
           </a:xfrm>
           <a:prstGeom prst="rect">
@@ -2678,13 +2784,13 @@
       </p:sp>
       <p:sp>
         <p:nvSpPr>
-          <p:cNvPr id="46" name="Text 41"/>
-          <p:cNvSpPr txBox="1"/>
-          <p:nvPr/>
-        </p:nvSpPr>
-        <p:spPr>
-          <a:xfrm>
-            <a:off x="658368" y="8646399"/>
+          <p:cNvPr id="49" name="Text 44"/>
+          <p:cNvSpPr txBox="1"/>
+          <p:nvPr/>
+        </p:nvSpPr>
+        <p:spPr>
+          <a:xfrm>
+            <a:off x="658368" y="9220429"/>
             <a:ext cx="2939796" cy="627583"/>
           </a:xfrm>
           <a:prstGeom prst="rect">
@@ -2712,7 +2818,7 @@
                 <a:ea typeface="Nunito" pitchFamily="34" charset="-122"/>
                 <a:cs typeface="Nunito" pitchFamily="34" charset="-120"/>
               </a:rPr>
-              <a:t>Q4 deliveries at or above 323 with free cash flow before customer financing of at least EUR 4.5bn; a decision to lift the A350 rate above 12 a month; Project Bromo signed in 2026.</a:t>
+              <a:t>Q4 deliveries at or above 323 with free cash flow before customer financing of at least EUR 4.5bn; the EUR 5bn buyback launched before year-end; Project Bromo signed in 2026 as planned.</a:t>
             </a:r>
             <a:endParaRPr lang="en-US" sz="870" dirty="0"/>
           </a:p>
@@ -2720,13 +2826,13 @@
       </p:sp>
       <p:sp>
         <p:nvSpPr>
-          <p:cNvPr id="47" name="Text 42"/>
-          <p:cNvSpPr txBox="1"/>
-          <p:nvPr/>
-        </p:nvSpPr>
-        <p:spPr>
-          <a:xfrm>
-            <a:off x="3963924" y="8454375"/>
+          <p:cNvPr id="50" name="Text 45"/>
+          <p:cNvSpPr txBox="1"/>
+          <p:nvPr/>
+        </p:nvSpPr>
+        <p:spPr>
+          <a:xfrm>
+            <a:off x="3963924" y="9028405"/>
             <a:ext cx="2939796" cy="155448"/>
           </a:xfrm>
           <a:prstGeom prst="rect">
@@ -2759,13 +2865,13 @@
       </p:sp>
       <p:sp>
         <p:nvSpPr>
-          <p:cNvPr id="48" name="Text 43"/>
-          <p:cNvSpPr txBox="1"/>
-          <p:nvPr/>
-        </p:nvSpPr>
-        <p:spPr>
-          <a:xfrm>
-            <a:off x="3963924" y="8646399"/>
+          <p:cNvPr id="51" name="Text 46"/>
+          <p:cNvSpPr txBox="1"/>
+          <p:nvPr/>
+        </p:nvSpPr>
+        <p:spPr>
+          <a:xfrm>
+            <a:off x="3963924" y="9220429"/>
             <a:ext cx="2939796" cy="627583"/>
           </a:xfrm>
           <a:prstGeom prst="rect">
@@ -2801,13 +2907,13 @@
       </p:sp>
       <p:sp>
         <p:nvSpPr>
-          <p:cNvPr id="49" name="Shape 44"/>
+          <p:cNvPr id="52" name="Shape 47"/>
           <p:cNvSpPr/>
           <p:nvPr/>
         </p:nvSpPr>
         <p:spPr>
           <a:xfrm>
-            <a:off x="539496" y="7151431"/>
+            <a:off x="539496" y="7725461"/>
             <a:ext cx="6483096" cy="2195703"/>
           </a:xfrm>
           <a:prstGeom prst="roundRect">
@@ -3137,7 +3243,7 @@
                 <a:ea typeface="Nunito" pitchFamily="34" charset="-122"/>
                 <a:cs typeface="Nunito" pitchFamily="34" charset="-120"/>
               </a:rPr>
-              <a:t>The reaction diverged from the misses: the shares closed 3.3% higher on 29 October, against 0.8% for the Stoxx Europe 600. Confirmed drivers: the 2026 guide held; management said the A321 stringer issue would not push deliveries toward the low end of the 850 to 890 range nor affect 2027; commercial margins beat; and nine-month net orders of 1,105 lifted the backlog to 9,310 aircraft, with defence orders up 70%. We think relief did the rest: the shares went into the print 12% below their January peak, at 22.9x, under the one-year average of 24.2x.</a:t>
+              <a:t>The reaction diverged from the misses: the shares closed 3.3% higher on 29 October, against 0.8% for the Stoxx Europe 600. Confirmed drivers: the guide held; management said the A321 stringer issue would not push deliveries toward the low end of the 850 to 890 range nor affect 2027; commercial margins beat; and the CFO said the plan to start the EUR 5bn buyback in the second half was unchanged. We think relief did the rest: the shares went into the print 12% below their January peak, at 22.9x, under the one-year average of 24.2x.</a:t>
             </a:r>
             <a:endParaRPr lang="en-US" sz="870" dirty="0"/>
           </a:p>
@@ -3218,7 +3324,7 @@
                 <a:ea typeface="Nunito" pitchFamily="34" charset="-122"/>
                 <a:cs typeface="Nunito" pitchFamily="34" charset="-120"/>
               </a:rPr>
-              <a:t>The unchanged guide of about 870 deliveries, EUR 7.5bn of adjusted EBIT and EUR 4.5bn of free cash flow before customer financing leaves a heavy Q4: about 323 deliveries, 37 more than a year earlier; about EUR 3.0bn of EBIT, roughly flat as the A220 mix, Spirit costs and back-loaded R&amp;D absorb the volume; and about EUR 5.8bn of cash, which depends on unwinding the inventory built this year. Engines remain the pacing item in 2027, and Airbus will not build extra airframes ahead of them. An A350 rate above 12 is under review. The 2029 outlook assumes USD 1.22, each cent worth about EUR 250m of EBIT.</a:t>
+              <a:t>The unchanged guide of about 870 deliveries, EUR 7.5bn of adjusted EBIT and EUR 4.5bn of free cash flow before customer financing leaves a heavy Q4: about 323 deliveries, 37 more than a year earlier; about EUR 3.0bn of EBIT, roughly flat as the A220 mix, Spirit costs and back-loaded R&amp;D absorb the volume; and about EUR 5.8bn of cash, which depends on unwinding the inventory built this year. Engines pace 2027, and Airbus will not build extra airframes ahead of them. An A350 rate above 12 is under review, and the 2029 target set in July, EUR 12bn to 13bn of adjusted EBIT at USD 1.22, stands.</a:t>
             </a:r>
             <a:endParaRPr lang="en-US" sz="870" dirty="0"/>
           </a:p>

</xml_diff>